<commit_message>
Rebuild Lecture-5 with charts and visual layouts
5 embedded images: accuracy trap comparison, confusion matrix heatmap,
precision/recall/F1 metric cards, ROC curve, precision-recall tradeoff
chart. Uses 2-Column, Bullets+Pull Quote, and Title Only layouts.
</commit_message>
<xml_diff>
--- a/stage1_classic_ml/05_model_evaluation/Lecture-5-Model-Evaluation.pptx
+++ b/stage1_classic_ml/05_model_evaluation/Lecture-5-Model-Evaluation.pptx
@@ -30,6 +30,8 @@
     <p:sldId id="272" r:id="rId28"/>
     <p:sldId id="273" r:id="rId29"/>
     <p:sldId id="274" r:id="rId30"/>
+    <p:sldId id="275" r:id="rId31"/>
+    <p:sldId id="276" r:id="rId32"/>
   </p:sldIdLst>
   <p:sldSz cx="12188825" cy="6858000"/>
   <p:notesSz cx="7010400" cy="9296400"/>
@@ -8414,69 +8416,35 @@
           <a:lstStyle/>
           <a:p>
             <a:r>
-              <a:t>F1 Score — Balancing Both</a:t>
-            </a:r>
-          </a:p>
-        </p:txBody>
-      </p:sp>
-      <p:sp>
-        <p:nvSpPr>
-          <p:cNvPr id="3" name="Content Placeholder 2"/>
-          <p:cNvSpPr>
-            <a:spLocks noGrp="1"/>
-          </p:cNvSpPr>
-          <p:nvPr>
-            <p:ph idx="1"/>
-          </p:nvPr>
-        </p:nvSpPr>
-        <p:spPr/>
-        <p:txBody>
-          <a:bodyPr/>
-          <a:lstStyle/>
-          <a:p>
-            <a:pPr/>
-            <a:r>
-              <a:t>F1 = 2 × (Precision × Recall) / (Precision + Recall)</a:t>
-            </a:r>
-          </a:p>
-          <a:p>
-            <a:pPr/>
-            <a:r>
-              <a:t>The harmonic mean of precision and recall</a:t>
-            </a:r>
-          </a:p>
-          <a:p>
-            <a:pPr/>
-            <a:r>
-              <a:t>A single number that balances both metrics</a:t>
-            </a:r>
-          </a:p>
-          <a:p>
-            <a:pPr lvl="1"/>
-            <a:r>
-              <a:t>F1 = 1.0 → perfect precision and recall</a:t>
-            </a:r>
-          </a:p>
-          <a:p>
-            <a:pPr lvl="1"/>
-            <a:r>
-              <a:t>F1 = 0.0 → complete failure on at least one metric</a:t>
-            </a:r>
-          </a:p>
-          <a:p>
-            <a:pPr/>
-            <a:r>
-              <a:t>Use F1 when you need a single metric to compare models</a:t>
-            </a:r>
-          </a:p>
-          <a:p>
-            <a:pPr/>
-            <a:r>
-              <a:t>Especially useful when classes are imbalanced</a:t>
-            </a:r>
-          </a:p>
-        </p:txBody>
-      </p:sp>
+              <a:t>The Three Key Metrics for Security ML</a:t>
+            </a:r>
+          </a:p>
+        </p:txBody>
+      </p:sp>
+      <p:pic>
+        <p:nvPicPr>
+          <p:cNvPr id="3" name="Picture 2" descr="eval_metrics.png"/>
+          <p:cNvPicPr>
+            <a:picLocks noChangeAspect="1"/>
+          </p:cNvPicPr>
+          <p:nvPr/>
+        </p:nvPicPr>
+        <p:blipFill>
+          <a:blip r:embed="rId2"/>
+          <a:stretch>
+            <a:fillRect/>
+          </a:stretch>
+        </p:blipFill>
+        <p:spPr>
+          <a:xfrm>
+            <a:off x="274320" y="1371600"/>
+            <a:ext cx="11430000" cy="4676862"/>
+          </a:xfrm>
+          <a:prstGeom prst="rect">
+            <a:avLst/>
+          </a:prstGeom>
+        </p:spPr>
+      </p:pic>
     </p:spTree>
   </p:cSld>
   <p:clrMapOvr>
@@ -8497,12 +8465,12 @@
       <p:grpSpPr/>
       <p:sp>
         <p:nvSpPr>
-          <p:cNvPr id="2" name="Text Placeholder 1"/>
+          <p:cNvPr id="2" name="Title 1"/>
           <p:cNvSpPr>
             <a:spLocks noGrp="1"/>
           </p:cNvSpPr>
           <p:nvPr>
-            <p:ph type="body" idx="13" sz="quarter"/>
+            <p:ph type="title"/>
           </p:nvPr>
         </p:nvSpPr>
         <p:spPr/>
@@ -8511,24 +8479,19 @@
           <a:lstStyle/>
           <a:p>
             <a:r>
-              <a:t>ROC Curve</a:t>
-            </a:r>
-          </a:p>
-          <a:p>
-            <a:r>
-              <a:t>and AUC</a:t>
-            </a:r>
-          </a:p>
-        </p:txBody>
-      </p:sp>
-      <p:sp>
-        <p:nvSpPr>
-          <p:cNvPr id="3" name="Text Placeholder 2"/>
+              <a:t>When Each Metric Matters Most</a:t>
+            </a:r>
+          </a:p>
+        </p:txBody>
+      </p:sp>
+      <p:sp>
+        <p:nvSpPr>
+          <p:cNvPr id="3" name="Content Placeholder 2"/>
           <p:cNvSpPr>
             <a:spLocks noGrp="1"/>
           </p:cNvSpPr>
           <p:nvPr>
-            <p:ph type="body" idx="16" sz="quarter"/>
+            <p:ph idx="2" sz="half"/>
           </p:nvPr>
         </p:nvSpPr>
         <p:spPr/>
@@ -8536,8 +8499,91 @@
           <a:bodyPr/>
           <a:lstStyle/>
           <a:p>
-            <a:r>
-              <a:t>04</a:t>
+            <a:pPr/>
+            <a:r>
+              <a:t>Prioritise Precision when:</a:t>
+            </a:r>
+          </a:p>
+          <a:p>
+            <a:pPr/>
+          </a:p>
+          <a:p>
+            <a:pPr lvl="1"/>
+            <a:r>
+              <a:t>Automated blocking rules</a:t>
+            </a:r>
+          </a:p>
+          <a:p>
+            <a:pPr lvl="1"/>
+            <a:r>
+              <a:t>High-cost response actions</a:t>
+            </a:r>
+          </a:p>
+          <a:p>
+            <a:pPr lvl="1"/>
+            <a:r>
+              <a:t>(isolating a production server)</a:t>
+            </a:r>
+          </a:p>
+          <a:p>
+            <a:pPr/>
+          </a:p>
+          <a:p>
+            <a:pPr/>
+            <a:r>
+              <a:t>You cannot afford false alarms</a:t>
+            </a:r>
+          </a:p>
+        </p:txBody>
+      </p:sp>
+      <p:sp>
+        <p:nvSpPr>
+          <p:cNvPr id="4" name="Content Placeholder 3"/>
+          <p:cNvSpPr>
+            <a:spLocks noGrp="1"/>
+          </p:cNvSpPr>
+          <p:nvPr>
+            <p:ph idx="12" sz="half"/>
+          </p:nvPr>
+        </p:nvSpPr>
+        <p:spPr/>
+        <p:txBody>
+          <a:bodyPr/>
+          <a:lstStyle/>
+          <a:p>
+            <a:pPr/>
+            <a:r>
+              <a:t>Prioritise Recall when:</a:t>
+            </a:r>
+          </a:p>
+          <a:p>
+            <a:pPr/>
+          </a:p>
+          <a:p>
+            <a:pPr lvl="1"/>
+            <a:r>
+              <a:t>Critical infrastructure monitoring</a:t>
+            </a:r>
+          </a:p>
+          <a:p>
+            <a:pPr lvl="1"/>
+            <a:r>
+              <a:t>Compliance requirements</a:t>
+            </a:r>
+          </a:p>
+          <a:p>
+            <a:pPr lvl="1"/>
+            <a:r>
+              <a:t>(must detect specific threat types)</a:t>
+            </a:r>
+          </a:p>
+          <a:p>
+            <a:pPr/>
+          </a:p>
+          <a:p>
+            <a:pPr/>
+            <a:r>
+              <a:t>You cannot afford to miss an attack</a:t>
             </a:r>
           </a:p>
         </p:txBody>
@@ -8562,12 +8608,12 @@
       <p:grpSpPr/>
       <p:sp>
         <p:nvSpPr>
-          <p:cNvPr id="2" name="Title 1"/>
+          <p:cNvPr id="2" name="Text Placeholder 1"/>
           <p:cNvSpPr>
             <a:spLocks noGrp="1"/>
           </p:cNvSpPr>
           <p:nvPr>
-            <p:ph type="title"/>
+            <p:ph type="body" idx="13" sz="quarter"/>
           </p:nvPr>
         </p:nvSpPr>
         <p:spPr/>
@@ -8576,19 +8622,24 @@
           <a:lstStyle/>
           <a:p>
             <a:r>
-              <a:t>ROC Curve and AUC</a:t>
-            </a:r>
-          </a:p>
-        </p:txBody>
-      </p:sp>
-      <p:sp>
-        <p:nvSpPr>
-          <p:cNvPr id="3" name="Content Placeholder 2"/>
+              <a:t>ROC Curve</a:t>
+            </a:r>
+          </a:p>
+          <a:p>
+            <a:r>
+              <a:t>and AUC</a:t>
+            </a:r>
+          </a:p>
+        </p:txBody>
+      </p:sp>
+      <p:sp>
+        <p:nvSpPr>
+          <p:cNvPr id="3" name="Text Placeholder 2"/>
           <p:cNvSpPr>
             <a:spLocks noGrp="1"/>
           </p:cNvSpPr>
           <p:nvPr>
-            <p:ph idx="1"/>
+            <p:ph type="body" idx="16" sz="quarter"/>
           </p:nvPr>
         </p:nvSpPr>
         <p:spPr/>
@@ -8596,45 +8647,8 @@
           <a:bodyPr/>
           <a:lstStyle/>
           <a:p>
-            <a:pPr/>
-            <a:r>
-              <a:t>ROC: plots True Positive Rate vs False Positive Rate across all thresholds</a:t>
-            </a:r>
-          </a:p>
-          <a:p>
-            <a:pPr/>
-            <a:r>
-              <a:t>AUC (Area Under the Curve) summarises this in one number</a:t>
-            </a:r>
-          </a:p>
-          <a:p>
-            <a:pPr lvl="1"/>
-            <a:r>
-              <a:t>AUC = 1.0 → perfect separation between classes</a:t>
-            </a:r>
-          </a:p>
-          <a:p>
-            <a:pPr lvl="1"/>
-            <a:r>
-              <a:t>AUC = 0.5 → no better than a coin flip</a:t>
-            </a:r>
-          </a:p>
-          <a:p>
-            <a:pPr/>
-            <a:r>
-              <a:t>A good security model: AUC &gt; 0.85</a:t>
-            </a:r>
-          </a:p>
-          <a:p>
-            <a:pPr/>
-            <a:r>
-              <a:t>The ROC curve shows model quality independent of threshold choice</a:t>
-            </a:r>
-          </a:p>
-          <a:p>
-            <a:pPr/>
-            <a:r>
-              <a:t>Useful for comparing different models on the same dataset</a:t>
+            <a:r>
+              <a:t>04</a:t>
             </a:r>
           </a:p>
         </p:txBody>
@@ -8659,12 +8673,12 @@
       <p:grpSpPr/>
       <p:sp>
         <p:nvSpPr>
-          <p:cNvPr id="2" name="Text Placeholder 1"/>
+          <p:cNvPr id="2" name="Title 1"/>
           <p:cNvSpPr>
             <a:spLocks noGrp="1"/>
           </p:cNvSpPr>
           <p:nvPr>
-            <p:ph type="body" idx="13" sz="quarter"/>
+            <p:ph type="title"/>
           </p:nvPr>
         </p:nvSpPr>
         <p:spPr/>
@@ -8673,32 +8687,35 @@
           <a:lstStyle/>
           <a:p>
             <a:r>
-              <a:t>Threshold Tuning</a:t>
-            </a:r>
-          </a:p>
-        </p:txBody>
-      </p:sp>
-      <p:sp>
-        <p:nvSpPr>
-          <p:cNvPr id="3" name="Text Placeholder 2"/>
-          <p:cNvSpPr>
-            <a:spLocks noGrp="1"/>
-          </p:cNvSpPr>
-          <p:nvPr>
-            <p:ph type="body" idx="16" sz="quarter"/>
-          </p:nvPr>
-        </p:nvSpPr>
-        <p:spPr/>
-        <p:txBody>
-          <a:bodyPr/>
-          <a:lstStyle/>
-          <a:p>
-            <a:r>
-              <a:t>05</a:t>
-            </a:r>
-          </a:p>
-        </p:txBody>
-      </p:sp>
+              <a:t>ROC Curve — Model Quality Across All Thresholds</a:t>
+            </a:r>
+          </a:p>
+        </p:txBody>
+      </p:sp>
+      <p:pic>
+        <p:nvPicPr>
+          <p:cNvPr id="3" name="Picture 2" descr="eval_roc.png"/>
+          <p:cNvPicPr>
+            <a:picLocks noChangeAspect="1"/>
+          </p:cNvPicPr>
+          <p:nvPr/>
+        </p:nvPicPr>
+        <p:blipFill>
+          <a:blip r:embed="rId2"/>
+          <a:stretch>
+            <a:fillRect/>
+          </a:stretch>
+        </p:blipFill>
+        <p:spPr>
+          <a:xfrm>
+            <a:off x="2926080" y="1097280"/>
+            <a:ext cx="6400800" cy="5542892"/>
+          </a:xfrm>
+          <a:prstGeom prst="rect">
+            <a:avLst/>
+          </a:prstGeom>
+        </p:spPr>
+      </p:pic>
     </p:spTree>
   </p:cSld>
   <p:clrMapOvr>
@@ -8733,7 +8750,7 @@
           <a:lstStyle/>
           <a:p>
             <a:r>
-              <a:t>The Precision-Recall Tradeoff</a:t>
+              <a:t>Reading the ROC Curve and AUC</a:t>
             </a:r>
           </a:p>
         </p:txBody>
@@ -8755,49 +8772,43 @@
           <a:p>
             <a:pPr/>
             <a:r>
-              <a:t>Lowering the decision threshold:</a:t>
+              <a:t>ROC plots True Positive Rate vs False Positive Rate across all thresholds</a:t>
+            </a:r>
+          </a:p>
+          <a:p>
+            <a:pPr/>
+            <a:r>
+              <a:t>AUC (Area Under Curve) summarises this in one number:</a:t>
             </a:r>
           </a:p>
           <a:p>
             <a:pPr lvl="1"/>
             <a:r>
-              <a:t>Catches more attacks → higher recall</a:t>
+              <a:t>AUC = 1.0 → perfect separation between classes</a:t>
             </a:r>
           </a:p>
           <a:p>
             <a:pPr lvl="1"/>
             <a:r>
-              <a:t>Generates more false alarms → lower precision</a:t>
+              <a:t>AUC = 0.5 → no better than random (coin flip)</a:t>
             </a:r>
           </a:p>
           <a:p>
             <a:pPr/>
             <a:r>
-              <a:t>Raising the decision threshold:</a:t>
-            </a:r>
-          </a:p>
-          <a:p>
-            <a:pPr lvl="1"/>
-            <a:r>
-              <a:t>Fewer false alarms → higher precision</a:t>
-            </a:r>
-          </a:p>
-          <a:p>
-            <a:pPr lvl="1"/>
-            <a:r>
-              <a:t>Misses more subtle attacks → lower recall</a:t>
+              <a:t>A good security model: AUC &gt; 0.85</a:t>
             </a:r>
           </a:p>
           <a:p>
             <a:pPr/>
             <a:r>
-              <a:t>You cannot maximise both — there is always a tradeoff</a:t>
+              <a:t>The further the curve pushes into the top-left corner, the better</a:t>
             </a:r>
           </a:p>
           <a:p>
             <a:pPr/>
             <a:r>
-              <a:t>The right balance depends on your organisation</a:t>
+              <a:t>Useful for comparing different models on the same dataset</a:t>
             </a:r>
           </a:p>
         </p:txBody>
@@ -8822,12 +8833,12 @@
       <p:grpSpPr/>
       <p:sp>
         <p:nvSpPr>
-          <p:cNvPr id="2" name="Title 1"/>
+          <p:cNvPr id="2" name="Text Placeholder 1"/>
           <p:cNvSpPr>
             <a:spLocks noGrp="1"/>
           </p:cNvSpPr>
           <p:nvPr>
-            <p:ph type="title"/>
+            <p:ph type="body" idx="13" sz="quarter"/>
           </p:nvPr>
         </p:nvSpPr>
         <p:spPr/>
@@ -8836,19 +8847,24 @@
           <a:lstStyle/>
           <a:p>
             <a:r>
-              <a:t>Choosing the Right Threshold</a:t>
-            </a:r>
-          </a:p>
-        </p:txBody>
-      </p:sp>
-      <p:sp>
-        <p:nvSpPr>
-          <p:cNvPr id="3" name="Content Placeholder 2"/>
+              <a:t>Threshold</a:t>
+            </a:r>
+          </a:p>
+          <a:p>
+            <a:r>
+              <a:t>Tuning</a:t>
+            </a:r>
+          </a:p>
+        </p:txBody>
+      </p:sp>
+      <p:sp>
+        <p:nvSpPr>
+          <p:cNvPr id="3" name="Text Placeholder 2"/>
           <p:cNvSpPr>
             <a:spLocks noGrp="1"/>
           </p:cNvSpPr>
           <p:nvPr>
-            <p:ph idx="1"/>
+            <p:ph type="body" idx="16" sz="quarter"/>
           </p:nvPr>
         </p:nvSpPr>
         <p:spPr/>
@@ -8856,51 +8872,8 @@
           <a:bodyPr/>
           <a:lstStyle/>
           <a:p>
-            <a:pPr/>
-            <a:r>
-              <a:t>SOC with large analyst team:</a:t>
-            </a:r>
-          </a:p>
-          <a:p>
-            <a:pPr lvl="1"/>
-            <a:r>
-              <a:t>Can handle more false alarms → lower threshold, higher recall</a:t>
-            </a:r>
-          </a:p>
-          <a:p>
-            <a:pPr lvl="1"/>
-            <a:r>
-              <a:t>Priority: don't miss any attacks</a:t>
-            </a:r>
-          </a:p>
-          <a:p>
-            <a:pPr/>
-            <a:r>
-              <a:t>Automated blocking rule:</a:t>
-            </a:r>
-          </a:p>
-          <a:p>
-            <a:pPr lvl="1"/>
-            <a:r>
-              <a:t>Must be high confidence → higher threshold, higher precision</a:t>
-            </a:r>
-          </a:p>
-          <a:p>
-            <a:pPr lvl="1"/>
-            <a:r>
-              <a:t>Priority: don't block legitimate traffic</a:t>
-            </a:r>
-          </a:p>
-          <a:p>
-            <a:pPr/>
-            <a:r>
-              <a:t>There is no universal 'correct' threshold</a:t>
-            </a:r>
-          </a:p>
-          <a:p>
-            <a:pPr/>
-            <a:r>
-              <a:t>It is a business decision informed by the metrics</a:t>
+            <a:r>
+              <a:t>05</a:t>
             </a:r>
           </a:p>
         </p:txBody>
@@ -8925,12 +8898,12 @@
       <p:grpSpPr/>
       <p:sp>
         <p:nvSpPr>
-          <p:cNvPr id="2" name="Text Placeholder 1"/>
+          <p:cNvPr id="2" name="Title 1"/>
           <p:cNvSpPr>
             <a:spLocks noGrp="1"/>
           </p:cNvSpPr>
           <p:nvPr>
-            <p:ph type="body" idx="13" sz="quarter"/>
+            <p:ph type="title"/>
           </p:nvPr>
         </p:nvSpPr>
         <p:spPr/>
@@ -8939,32 +8912,35 @@
           <a:lstStyle/>
           <a:p>
             <a:r>
-              <a:t>Workshop</a:t>
-            </a:r>
-          </a:p>
-        </p:txBody>
-      </p:sp>
-      <p:sp>
-        <p:nvSpPr>
-          <p:cNvPr id="3" name="Text Placeholder 2"/>
-          <p:cNvSpPr>
-            <a:spLocks noGrp="1"/>
-          </p:cNvSpPr>
-          <p:nvPr>
-            <p:ph type="body" idx="16" sz="quarter"/>
-          </p:nvPr>
-        </p:nvSpPr>
-        <p:spPr/>
-        <p:txBody>
-          <a:bodyPr/>
-          <a:lstStyle/>
-          <a:p>
-            <a:r>
-              <a:t>06</a:t>
-            </a:r>
-          </a:p>
-        </p:txBody>
-      </p:sp>
+              <a:t>The Precision-Recall Tradeoff</a:t>
+            </a:r>
+          </a:p>
+        </p:txBody>
+      </p:sp>
+      <p:pic>
+        <p:nvPicPr>
+          <p:cNvPr id="3" name="Picture 2" descr="eval_tradeoff.png"/>
+          <p:cNvPicPr>
+            <a:picLocks noChangeAspect="1"/>
+          </p:cNvPicPr>
+          <p:nvPr/>
+        </p:nvPicPr>
+        <p:blipFill>
+          <a:blip r:embed="rId2"/>
+          <a:stretch>
+            <a:fillRect/>
+          </a:stretch>
+        </p:blipFill>
+        <p:spPr>
+          <a:xfrm>
+            <a:off x="1554480" y="1371600"/>
+            <a:ext cx="9144000" cy="5103127"/>
+          </a:xfrm>
+          <a:prstGeom prst="rect">
+            <a:avLst/>
+          </a:prstGeom>
+        </p:spPr>
+      </p:pic>
     </p:spTree>
   </p:cSld>
   <p:clrMapOvr>
@@ -8999,7 +8975,7 @@
           <a:lstStyle/>
           <a:p>
             <a:r>
-              <a:t>Workshop — 5 Exercises</a:t>
+              <a:t>Choosing the Right Threshold</a:t>
             </a:r>
           </a:p>
         </p:txBody>
@@ -9011,7 +8987,7 @@
             <a:spLocks noGrp="1"/>
           </p:cNvSpPr>
           <p:nvPr>
-            <p:ph idx="1"/>
+            <p:ph idx="2" sz="half"/>
           </p:nvPr>
         </p:nvSpPr>
         <p:spPr/>
@@ -9021,31 +8997,89 @@
           <a:p>
             <a:pPr/>
             <a:r>
-              <a:t>Exercise 1: The accuracy trap — DummyClassifier, 95% accuracy catches 0 attacks</a:t>
+              <a:t>SOC with Large Analyst Team</a:t>
             </a:r>
           </a:p>
           <a:p>
             <a:pPr/>
-            <a:r>
-              <a:t>Exercise 2: Confusion matrix — TP/TN/FP/FN, compute manually and with sklearn</a:t>
-            </a:r>
           </a:p>
           <a:p>
             <a:pPr/>
             <a:r>
-              <a:t>Exercise 3: Precision, recall, F1 — classification_report, security tradeoffs</a:t>
+              <a:t>Can handle more false alarms</a:t>
             </a:r>
           </a:p>
           <a:p>
             <a:pPr/>
             <a:r>
-              <a:t>Exercise 4: ROC and AUC — ROC curve, compare three models</a:t>
+              <a:t>Lower threshold, higher recall</a:t>
             </a:r>
           </a:p>
           <a:p>
             <a:pPr/>
             <a:r>
-              <a:t>Exercise 5: Threshold tuning — sensitivity analysis, pick for your use case</a:t>
+              <a:t>Priority: don't miss any attacks</a:t>
+            </a:r>
+          </a:p>
+          <a:p>
+            <a:pPr/>
+          </a:p>
+          <a:p>
+            <a:pPr/>
+            <a:r>
+              <a:t>Typical threshold: 0.3 – 0.4</a:t>
+            </a:r>
+          </a:p>
+        </p:txBody>
+      </p:sp>
+      <p:sp>
+        <p:nvSpPr>
+          <p:cNvPr id="4" name="Content Placeholder 3"/>
+          <p:cNvSpPr>
+            <a:spLocks noGrp="1"/>
+          </p:cNvSpPr>
+          <p:nvPr>
+            <p:ph idx="12" sz="half"/>
+          </p:nvPr>
+        </p:nvSpPr>
+        <p:spPr/>
+        <p:txBody>
+          <a:bodyPr/>
+          <a:lstStyle/>
+          <a:p>
+            <a:pPr/>
+            <a:r>
+              <a:t>Automated Blocking Rule</a:t>
+            </a:r>
+          </a:p>
+          <a:p>
+            <a:pPr/>
+          </a:p>
+          <a:p>
+            <a:pPr/>
+            <a:r>
+              <a:t>Must be high confidence</a:t>
+            </a:r>
+          </a:p>
+          <a:p>
+            <a:pPr/>
+            <a:r>
+              <a:t>Higher threshold, higher precision</a:t>
+            </a:r>
+          </a:p>
+          <a:p>
+            <a:pPr/>
+            <a:r>
+              <a:t>Priority: don't block legitimate traffic</a:t>
+            </a:r>
+          </a:p>
+          <a:p>
+            <a:pPr/>
+          </a:p>
+          <a:p>
+            <a:pPr/>
+            <a:r>
+              <a:t>Typical threshold: 0.7 – 0.8</a:t>
             </a:r>
           </a:p>
         </p:txBody>
@@ -9075,7 +9109,7 @@
             <a:spLocks noGrp="1"/>
           </p:cNvSpPr>
           <p:nvPr>
-            <p:ph type="body" idx="12" sz="quarter"/>
+            <p:ph type="body" idx="13" sz="quarter"/>
           </p:nvPr>
         </p:nvSpPr>
         <p:spPr/>
@@ -9083,51 +9117,20 @@
           <a:bodyPr/>
           <a:lstStyle/>
           <a:p>
-            <a:pPr/>
-            <a:r>
-              <a:t>Accuracy is misleading on imbalanced security data — a 99% model can catch 0 attacks</a:t>
-            </a:r>
-          </a:p>
-          <a:p>
-            <a:pPr/>
-            <a:r>
-              <a:t>Precision: 'how many alerts are real?' — Recall: 'how many attacks did we catch?'</a:t>
-            </a:r>
-          </a:p>
-          <a:p>
-            <a:pPr/>
-            <a:r>
-              <a:t>F1 balances both; ROC AUC measures overall class separation</a:t>
-            </a:r>
-          </a:p>
-          <a:p>
-            <a:pPr/>
-            <a:r>
-              <a:t>The confusion matrix shows exactly where errors happen</a:t>
-            </a:r>
-          </a:p>
-          <a:p>
-            <a:pPr/>
-            <a:r>
-              <a:t>Threshold tuning is a business decision, not a technical one</a:t>
-            </a:r>
-          </a:p>
-          <a:p>
-            <a:pPr/>
-            <a:r>
-              <a:t>Next: Stage 1 Project — Phishing URL Classifier</a:t>
-            </a:r>
-          </a:p>
-        </p:txBody>
-      </p:sp>
-      <p:sp>
-        <p:nvSpPr>
-          <p:cNvPr id="3" name="Title 2"/>
+            <a:r>
+              <a:t>Workshop</a:t>
+            </a:r>
+          </a:p>
+        </p:txBody>
+      </p:sp>
+      <p:sp>
+        <p:nvSpPr>
+          <p:cNvPr id="3" name="Text Placeholder 2"/>
           <p:cNvSpPr>
             <a:spLocks noGrp="1"/>
           </p:cNvSpPr>
           <p:nvPr>
-            <p:ph type="title"/>
+            <p:ph type="body" idx="16" sz="quarter"/>
           </p:nvPr>
         </p:nvSpPr>
         <p:spPr/>
@@ -9136,7 +9139,7 @@
           <a:lstStyle/>
           <a:p>
             <a:r>
-              <a:t>Summary</a:t>
+              <a:t>06</a:t>
             </a:r>
           </a:p>
         </p:txBody>
@@ -9161,12 +9164,12 @@
       <p:grpSpPr/>
       <p:sp>
         <p:nvSpPr>
-          <p:cNvPr id="2" name="Text Placeholder 1"/>
+          <p:cNvPr id="2" name="Title 1"/>
           <p:cNvSpPr>
             <a:spLocks noGrp="1"/>
           </p:cNvSpPr>
           <p:nvPr>
-            <p:ph type="body" idx="13" sz="quarter"/>
+            <p:ph type="title"/>
           </p:nvPr>
         </p:nvSpPr>
         <p:spPr/>
@@ -9175,19 +9178,19 @@
           <a:lstStyle/>
           <a:p>
             <a:r>
-              <a:t>Next → Stage 1 Project: Phishing URL Classifier</a:t>
-            </a:r>
-          </a:p>
-        </p:txBody>
-      </p:sp>
-      <p:sp>
-        <p:nvSpPr>
-          <p:cNvPr id="3" name="Text Placeholder 2"/>
+              <a:t>Workshop — 5 Exercises</a:t>
+            </a:r>
+          </a:p>
+        </p:txBody>
+      </p:sp>
+      <p:sp>
+        <p:nvSpPr>
+          <p:cNvPr id="3" name="Content Placeholder 2"/>
           <p:cNvSpPr>
             <a:spLocks noGrp="1"/>
           </p:cNvSpPr>
           <p:nvPr>
-            <p:ph type="body" idx="14" sz="quarter"/>
+            <p:ph idx="1"/>
           </p:nvPr>
         </p:nvSpPr>
         <p:spPr/>
@@ -9195,8 +9198,42 @@
           <a:bodyPr/>
           <a:lstStyle/>
           <a:p>
-            <a:r>
-              <a:t>Model Evaluation</a:t>
+            <a:pPr/>
+            <a:r>
+              <a:t>Exercise 1: The accuracy trap — DummyClassifier, 95% accuracy that catches 0 attacks</a:t>
+            </a:r>
+          </a:p>
+          <a:p>
+            <a:pPr/>
+            <a:r>
+              <a:t>Exercise 2: Confusion matrix — TP/TN/FP/FN, compute manually and with sklearn</a:t>
+            </a:r>
+          </a:p>
+          <a:p>
+            <a:pPr/>
+            <a:r>
+              <a:t>Exercise 3: Precision, recall, F1 — classification_report, security tradeoffs</a:t>
+            </a:r>
+          </a:p>
+          <a:p>
+            <a:pPr/>
+            <a:r>
+              <a:t>Exercise 4: ROC and AUC — ROC curve, compare three models visually</a:t>
+            </a:r>
+          </a:p>
+          <a:p>
+            <a:pPr/>
+            <a:r>
+              <a:t>Exercise 5: Threshold tuning — sensitivity analysis, pick for your use case</a:t>
+            </a:r>
+          </a:p>
+          <a:p>
+            <a:pPr/>
+          </a:p>
+          <a:p>
+            <a:pPr/>
+            <a:r>
+              <a:t>Each exercise: lecture.md → handson.md → solution_model_evaluation.py</a:t>
             </a:r>
           </a:p>
         </p:txBody>
@@ -9248,6 +9285,12 @@
           <a:p>
             <a:pPr/>
             <a:r>
+              <a:t>The confusion matrix</a:t>
+            </a:r>
+          </a:p>
+          <a:p>
+            <a:pPr/>
+            <a:r>
               <a:t>Precision, recall, and F1 score</a:t>
             </a:r>
           </a:p>
@@ -9294,6 +9337,157 @@
           <a:p>
             <a:r>
               <a:t>Agenda</a:t>
+            </a:r>
+          </a:p>
+        </p:txBody>
+      </p:sp>
+    </p:spTree>
+  </p:cSld>
+  <p:clrMapOvr>
+    <a:masterClrMapping/>
+  </p:clrMapOvr>
+</p:sld>
+</file>
+
+<file path=ppt/slides/slide20.xml><?xml version="1.0" encoding="utf-8"?>
+<p:sld xmlns:a="http://schemas.openxmlformats.org/drawingml/2006/main" xmlns:p="http://schemas.openxmlformats.org/presentationml/2006/main" xmlns:r="http://schemas.openxmlformats.org/officeDocument/2006/relationships">
+  <p:cSld>
+    <p:spTree>
+      <p:nvGrpSpPr>
+        <p:cNvPr id="1" name=""/>
+        <p:cNvGrpSpPr/>
+        <p:nvPr/>
+      </p:nvGrpSpPr>
+      <p:grpSpPr/>
+      <p:sp>
+        <p:nvSpPr>
+          <p:cNvPr id="2" name="Text Placeholder 1"/>
+          <p:cNvSpPr>
+            <a:spLocks noGrp="1"/>
+          </p:cNvSpPr>
+          <p:nvPr>
+            <p:ph type="body" idx="12" sz="quarter"/>
+          </p:nvPr>
+        </p:nvSpPr>
+        <p:spPr/>
+        <p:txBody>
+          <a:bodyPr/>
+          <a:lstStyle/>
+          <a:p>
+            <a:pPr/>
+            <a:r>
+              <a:t>Accuracy is misleading on imbalanced security data — 99% can catch 0 attacks</a:t>
+            </a:r>
+          </a:p>
+          <a:p>
+            <a:pPr/>
+            <a:r>
+              <a:t>The confusion matrix shows exactly where errors happen: TP, FP, TN, FN</a:t>
+            </a:r>
+          </a:p>
+          <a:p>
+            <a:pPr/>
+            <a:r>
+              <a:t>Precision: 'how many alerts are real?' — Recall: 'how many attacks did we catch?'</a:t>
+            </a:r>
+          </a:p>
+          <a:p>
+            <a:pPr/>
+            <a:r>
+              <a:t>F1 balances both; ROC AUC measures overall class separation</a:t>
+            </a:r>
+          </a:p>
+          <a:p>
+            <a:pPr/>
+            <a:r>
+              <a:t>Threshold tuning is a business decision: SOC team vs automated rule</a:t>
+            </a:r>
+          </a:p>
+          <a:p>
+            <a:pPr/>
+            <a:r>
+              <a:t>Next: Stage 1 Project — Phishing URL Classifier</a:t>
+            </a:r>
+          </a:p>
+        </p:txBody>
+      </p:sp>
+      <p:sp>
+        <p:nvSpPr>
+          <p:cNvPr id="3" name="Title 2"/>
+          <p:cNvSpPr>
+            <a:spLocks noGrp="1"/>
+          </p:cNvSpPr>
+          <p:nvPr>
+            <p:ph type="title"/>
+          </p:nvPr>
+        </p:nvSpPr>
+        <p:spPr/>
+        <p:txBody>
+          <a:bodyPr/>
+          <a:lstStyle/>
+          <a:p>
+            <a:r>
+              <a:t>Summary</a:t>
+            </a:r>
+          </a:p>
+        </p:txBody>
+      </p:sp>
+    </p:spTree>
+  </p:cSld>
+  <p:clrMapOvr>
+    <a:masterClrMapping/>
+  </p:clrMapOvr>
+</p:sld>
+</file>
+
+<file path=ppt/slides/slide21.xml><?xml version="1.0" encoding="utf-8"?>
+<p:sld xmlns:a="http://schemas.openxmlformats.org/drawingml/2006/main" xmlns:p="http://schemas.openxmlformats.org/presentationml/2006/main" xmlns:r="http://schemas.openxmlformats.org/officeDocument/2006/relationships">
+  <p:cSld>
+    <p:spTree>
+      <p:nvGrpSpPr>
+        <p:cNvPr id="1" name=""/>
+        <p:cNvGrpSpPr/>
+        <p:nvPr/>
+      </p:nvGrpSpPr>
+      <p:grpSpPr/>
+      <p:sp>
+        <p:nvSpPr>
+          <p:cNvPr id="2" name="Text Placeholder 1"/>
+          <p:cNvSpPr>
+            <a:spLocks noGrp="1"/>
+          </p:cNvSpPr>
+          <p:nvPr>
+            <p:ph type="body" idx="13" sz="quarter"/>
+          </p:nvPr>
+        </p:nvSpPr>
+        <p:spPr/>
+        <p:txBody>
+          <a:bodyPr/>
+          <a:lstStyle/>
+          <a:p>
+            <a:r>
+              <a:t>Next → Stage 1 Project: Phishing URL Classifier</a:t>
+            </a:r>
+          </a:p>
+        </p:txBody>
+      </p:sp>
+      <p:sp>
+        <p:nvSpPr>
+          <p:cNvPr id="3" name="Text Placeholder 2"/>
+          <p:cNvSpPr>
+            <a:spLocks noGrp="1"/>
+          </p:cNvSpPr>
+          <p:nvPr>
+            <p:ph type="body" idx="14" sz="quarter"/>
+          </p:nvPr>
+        </p:nvSpPr>
+        <p:spPr/>
+        <p:txBody>
+          <a:bodyPr/>
+          <a:lstStyle/>
+          <a:p>
+            <a:r>
+              <a:t>Model Evaluation</a:t>
             </a:r>
           </a:p>
         </p:txBody>
@@ -9332,7 +9526,12 @@
           <a:lstStyle/>
           <a:p>
             <a:r>
-              <a:t>The Accuracy Trap</a:t>
+              <a:t>The Accuracy</a:t>
+            </a:r>
+          </a:p>
+          <a:p>
+            <a:r>
+              <a:t>Trap</a:t>
             </a:r>
           </a:p>
         </p:txBody>
@@ -9397,70 +9596,30 @@
           </a:p>
         </p:txBody>
       </p:sp>
-      <p:sp>
-        <p:nvSpPr>
-          <p:cNvPr id="3" name="Content Placeholder 2"/>
-          <p:cNvSpPr>
-            <a:spLocks noGrp="1"/>
-          </p:cNvSpPr>
-          <p:nvPr>
-            <p:ph idx="1"/>
-          </p:nvPr>
-        </p:nvSpPr>
-        <p:spPr/>
-        <p:txBody>
-          <a:bodyPr/>
-          <a:lstStyle/>
-          <a:p>
-            <a:pPr/>
-            <a:r>
-              <a:t>Imagine: 10,000 connections per hour, 100 are attacks (1%)</a:t>
-            </a:r>
-          </a:p>
-          <a:p>
-            <a:pPr/>
-            <a:r>
-              <a:t>A model that always predicts 'benign':</a:t>
-            </a:r>
-          </a:p>
-          <a:p>
-            <a:pPr lvl="1"/>
-            <a:r>
-              <a:t>Accuracy = 99%</a:t>
-            </a:r>
-          </a:p>
-          <a:p>
-            <a:pPr lvl="1"/>
-            <a:r>
-              <a:t>Attacks caught = 0</a:t>
-            </a:r>
-          </a:p>
-          <a:p>
-            <a:pPr/>
-            <a:r>
-              <a:t>This is the class imbalance problem</a:t>
-            </a:r>
-          </a:p>
-          <a:p>
-            <a:pPr/>
-            <a:r>
-              <a:t>It is everywhere in security:</a:t>
-            </a:r>
-          </a:p>
-          <a:p>
-            <a:pPr lvl="1"/>
-            <a:r>
-              <a:t>Malware vs benign files, phishing vs legitimate URLs</a:t>
-            </a:r>
-          </a:p>
-          <a:p>
-            <a:pPr lvl="1"/>
-            <a:r>
-              <a:t>Network attacks vs normal traffic</a:t>
-            </a:r>
-          </a:p>
-        </p:txBody>
-      </p:sp>
+      <p:pic>
+        <p:nvPicPr>
+          <p:cNvPr id="3" name="Picture 2" descr="eval_accuracy_trap.png"/>
+          <p:cNvPicPr>
+            <a:picLocks noChangeAspect="1"/>
+          </p:cNvPicPr>
+          <p:nvPr/>
+        </p:nvPicPr>
+        <p:blipFill>
+          <a:blip r:embed="rId2"/>
+          <a:stretch>
+            <a:fillRect/>
+          </a:stretch>
+        </p:blipFill>
+        <p:spPr>
+          <a:xfrm>
+            <a:off x="1371600" y="1371600"/>
+            <a:ext cx="9418320" cy="3773670"/>
+          </a:xfrm>
+          <a:prstGeom prst="rect">
+            <a:avLst/>
+          </a:prstGeom>
+        </p:spPr>
+      </p:pic>
     </p:spTree>
   </p:cSld>
   <p:clrMapOvr>
@@ -9481,12 +9640,12 @@
       <p:grpSpPr/>
       <p:sp>
         <p:nvSpPr>
-          <p:cNvPr id="2" name="Text Placeholder 1"/>
+          <p:cNvPr id="2" name="Title 1"/>
           <p:cNvSpPr>
             <a:spLocks noGrp="1"/>
           </p:cNvSpPr>
           <p:nvPr>
-            <p:ph type="body" idx="13" sz="quarter"/>
+            <p:ph type="title"/>
           </p:nvPr>
         </p:nvSpPr>
         <p:spPr/>
@@ -9495,19 +9654,19 @@
           <a:lstStyle/>
           <a:p>
             <a:r>
-              <a:t>The Four Outcomes</a:t>
-            </a:r>
-          </a:p>
-        </p:txBody>
-      </p:sp>
-      <p:sp>
-        <p:nvSpPr>
-          <p:cNvPr id="3" name="Text Placeholder 2"/>
+              <a:t>The Class Imbalance Problem</a:t>
+            </a:r>
+          </a:p>
+        </p:txBody>
+      </p:sp>
+      <p:sp>
+        <p:nvSpPr>
+          <p:cNvPr id="3" name="Content Placeholder 2"/>
           <p:cNvSpPr>
             <a:spLocks noGrp="1"/>
           </p:cNvSpPr>
           <p:nvPr>
-            <p:ph type="body" idx="16" sz="quarter"/>
+            <p:ph idx="1"/>
           </p:nvPr>
         </p:nvSpPr>
         <p:spPr/>
@@ -9515,8 +9674,57 @@
           <a:bodyPr/>
           <a:lstStyle/>
           <a:p>
-            <a:r>
-              <a:t>02</a:t>
+            <a:pPr/>
+            <a:r>
+              <a:t>10,000 connections per hour. 100 are attacks (1%).</a:t>
+            </a:r>
+          </a:p>
+          <a:p>
+            <a:pPr/>
+            <a:r>
+              <a:t>A model that always predicts 'benign':</a:t>
+            </a:r>
+          </a:p>
+          <a:p>
+            <a:pPr lvl="1"/>
+            <a:r>
+              <a:t>Accuracy = 99%</a:t>
+            </a:r>
+          </a:p>
+          <a:p>
+            <a:pPr lvl="1"/>
+            <a:r>
+              <a:t>Attacks caught = 0</a:t>
+            </a:r>
+          </a:p>
+          <a:p>
+            <a:pPr/>
+            <a:r>
+              <a:t>This is everywhere in security:</a:t>
+            </a:r>
+          </a:p>
+          <a:p>
+            <a:pPr lvl="1"/>
+            <a:r>
+              <a:t>Network intrusion: 99% normal, 1% attack</a:t>
+            </a:r>
+          </a:p>
+          <a:p>
+            <a:pPr lvl="1"/>
+            <a:r>
+              <a:t>Malware: 95% benign, 5% malicious</a:t>
+            </a:r>
+          </a:p>
+          <a:p>
+            <a:pPr lvl="1"/>
+            <a:r>
+              <a:t>Fraud: 99.8% legitimate, 0.2% fraud</a:t>
+            </a:r>
+          </a:p>
+          <a:p>
+            <a:pPr/>
+            <a:r>
+              <a:t>You need metrics that account for this imbalance</a:t>
             </a:r>
           </a:p>
         </p:txBody>
@@ -9541,12 +9749,12 @@
       <p:grpSpPr/>
       <p:sp>
         <p:nvSpPr>
-          <p:cNvPr id="2" name="Title 1"/>
+          <p:cNvPr id="2" name="Text Placeholder 1"/>
           <p:cNvSpPr>
             <a:spLocks noGrp="1"/>
           </p:cNvSpPr>
           <p:nvPr>
-            <p:ph type="title"/>
+            <p:ph type="body" idx="13" sz="quarter"/>
           </p:nvPr>
         </p:nvSpPr>
         <p:spPr/>
@@ -9555,19 +9763,24 @@
           <a:lstStyle/>
           <a:p>
             <a:r>
-              <a:t>The Four Outcomes of Every Prediction</a:t>
-            </a:r>
-          </a:p>
-        </p:txBody>
-      </p:sp>
-      <p:sp>
-        <p:nvSpPr>
-          <p:cNvPr id="3" name="Content Placeholder 2"/>
+              <a:t>The Four Outcomes</a:t>
+            </a:r>
+          </a:p>
+          <a:p>
+            <a:r>
+              <a:t>&amp; Confusion Matrix</a:t>
+            </a:r>
+          </a:p>
+        </p:txBody>
+      </p:sp>
+      <p:sp>
+        <p:nvSpPr>
+          <p:cNvPr id="3" name="Text Placeholder 2"/>
           <p:cNvSpPr>
             <a:spLocks noGrp="1"/>
           </p:cNvSpPr>
           <p:nvPr>
-            <p:ph idx="1"/>
+            <p:ph type="body" idx="16" sz="quarter"/>
           </p:nvPr>
         </p:nvSpPr>
         <p:spPr/>
@@ -9575,51 +9788,8 @@
           <a:bodyPr/>
           <a:lstStyle/>
           <a:p>
-            <a:pPr/>
-            <a:r>
-              <a:t>True Positive (TP) — correctly identified an attack</a:t>
-            </a:r>
-          </a:p>
-          <a:p>
-            <a:pPr/>
-            <a:r>
-              <a:t>True Negative (TN) — correctly identified benign traffic</a:t>
-            </a:r>
-          </a:p>
-          <a:p>
-            <a:pPr/>
-            <a:r>
-              <a:t>False Positive (FP) — false alarm (benign flagged as attack)</a:t>
-            </a:r>
-          </a:p>
-          <a:p>
-            <a:pPr/>
-            <a:r>
-              <a:t>False Negative (FN) — missed attack (attack classified as benign)</a:t>
-            </a:r>
-          </a:p>
-          <a:p>
-            <a:pPr/>
-            <a:r>
-              <a:t>The confusion matrix shows all four in a grid:</a:t>
-            </a:r>
-          </a:p>
-          <a:p>
-            <a:pPr lvl="1"/>
-            <a:r>
-              <a:t>Diagonal = correct predictions (want these high)</a:t>
-            </a:r>
-          </a:p>
-          <a:p>
-            <a:pPr lvl="1"/>
-            <a:r>
-              <a:t>Off-diagonal = errors (want these low)</a:t>
-            </a:r>
-          </a:p>
-          <a:p>
-            <a:pPr/>
-            <a:r>
-              <a:t>In security: FN (missed attacks) is usually the most dangerous error</a:t>
+            <a:r>
+              <a:t>02</a:t>
             </a:r>
           </a:p>
         </p:txBody>
@@ -9644,12 +9814,12 @@
       <p:grpSpPr/>
       <p:sp>
         <p:nvSpPr>
-          <p:cNvPr id="2" name="Text Placeholder 1"/>
+          <p:cNvPr id="2" name="Title 1"/>
           <p:cNvSpPr>
             <a:spLocks noGrp="1"/>
           </p:cNvSpPr>
           <p:nvPr>
-            <p:ph type="body" idx="13" sz="quarter"/>
+            <p:ph type="title"/>
           </p:nvPr>
         </p:nvSpPr>
         <p:spPr/>
@@ -9658,37 +9828,35 @@
           <a:lstStyle/>
           <a:p>
             <a:r>
-              <a:t>Precision, Recall,</a:t>
-            </a:r>
-          </a:p>
-          <a:p>
-            <a:r>
-              <a:t>and F1</a:t>
-            </a:r>
-          </a:p>
-        </p:txBody>
-      </p:sp>
-      <p:sp>
-        <p:nvSpPr>
-          <p:cNvPr id="3" name="Text Placeholder 2"/>
-          <p:cNvSpPr>
-            <a:spLocks noGrp="1"/>
-          </p:cNvSpPr>
-          <p:nvPr>
-            <p:ph type="body" idx="16" sz="quarter"/>
-          </p:nvPr>
-        </p:nvSpPr>
-        <p:spPr/>
-        <p:txBody>
-          <a:bodyPr/>
-          <a:lstStyle/>
-          <a:p>
-            <a:r>
-              <a:t>03</a:t>
-            </a:r>
-          </a:p>
-        </p:txBody>
-      </p:sp>
+              <a:t>The Confusion Matrix — Every Prediction Falls Here</a:t>
+            </a:r>
+          </a:p>
+        </p:txBody>
+      </p:sp>
+      <p:pic>
+        <p:nvPicPr>
+          <p:cNvPr id="3" name="Picture 2" descr="eval_confusion.png"/>
+          <p:cNvPicPr>
+            <a:picLocks noChangeAspect="1"/>
+          </p:cNvPicPr>
+          <p:nvPr/>
+        </p:nvPicPr>
+        <p:blipFill>
+          <a:blip r:embed="rId2"/>
+          <a:stretch>
+            <a:fillRect/>
+          </a:stretch>
+        </p:blipFill>
+        <p:spPr>
+          <a:xfrm>
+            <a:off x="2926080" y="1188720"/>
+            <a:ext cx="6400800" cy="6444893"/>
+          </a:xfrm>
+          <a:prstGeom prst="rect">
+            <a:avLst/>
+          </a:prstGeom>
+        </p:spPr>
+      </p:pic>
     </p:spTree>
   </p:cSld>
   <p:clrMapOvr>
@@ -9709,7 +9877,59 @@
       <p:grpSpPr/>
       <p:sp>
         <p:nvSpPr>
-          <p:cNvPr id="2" name="Title 1"/>
+          <p:cNvPr id="2" name="Text Placeholder 1"/>
+          <p:cNvSpPr>
+            <a:spLocks noGrp="1"/>
+          </p:cNvSpPr>
+          <p:nvPr>
+            <p:ph type="body" idx="14" sz="quarter"/>
+          </p:nvPr>
+        </p:nvSpPr>
+        <p:spPr/>
+        <p:txBody>
+          <a:bodyPr/>
+          <a:lstStyle/>
+          <a:p>
+            <a:r>
+              <a:t>— Recall matters</a:t>
+            </a:r>
+          </a:p>
+        </p:txBody>
+      </p:sp>
+      <p:sp>
+        <p:nvSpPr>
+          <p:cNvPr id="3" name="Text Placeholder 2"/>
+          <p:cNvSpPr>
+            <a:spLocks noGrp="1"/>
+          </p:cNvSpPr>
+          <p:nvPr>
+            <p:ph type="body" idx="15" sz="quarter"/>
+          </p:nvPr>
+        </p:nvSpPr>
+        <p:spPr/>
+        <p:txBody>
+          <a:bodyPr/>
+          <a:lstStyle/>
+          <a:p>
+            <a:r>
+              <a:t>In security, FN (missed attacks)</a:t>
+            </a:r>
+          </a:p>
+          <a:p>
+            <a:r>
+              <a:t>is usually the most dangerous</a:t>
+            </a:r>
+          </a:p>
+          <a:p>
+            <a:r>
+              <a:t>error of all.</a:t>
+            </a:r>
+          </a:p>
+        </p:txBody>
+      </p:sp>
+      <p:sp>
+        <p:nvSpPr>
+          <p:cNvPr id="4" name="Title 3"/>
           <p:cNvSpPr>
             <a:spLocks noGrp="1"/>
           </p:cNvSpPr>
@@ -9723,19 +9943,19 @@
           <a:lstStyle/>
           <a:p>
             <a:r>
-              <a:t>Precision</a:t>
-            </a:r>
-          </a:p>
-        </p:txBody>
-      </p:sp>
-      <p:sp>
-        <p:nvSpPr>
-          <p:cNvPr id="3" name="Content Placeholder 2"/>
+              <a:t>Understanding the Four Outcomes</a:t>
+            </a:r>
+          </a:p>
+        </p:txBody>
+      </p:sp>
+      <p:sp>
+        <p:nvSpPr>
+          <p:cNvPr id="5" name="Text Placeholder 4"/>
           <p:cNvSpPr>
             <a:spLocks noGrp="1"/>
           </p:cNvSpPr>
           <p:nvPr>
-            <p:ph idx="1"/>
+            <p:ph type="body" idx="16" sz="quarter"/>
           </p:nvPr>
         </p:nvSpPr>
         <p:spPr/>
@@ -9745,43 +9965,25 @@
           <a:p>
             <a:pPr/>
             <a:r>
-              <a:t>"Of all the alerts my model fires, how many are real attacks?"</a:t>
+              <a:t>True Positive (TP) — correctly flagged an attack</a:t>
             </a:r>
           </a:p>
           <a:p>
             <a:pPr/>
             <a:r>
-              <a:t>Precision = TP / (TP + FP)</a:t>
+              <a:t>True Negative (TN) — correctly passed benign traffic</a:t>
             </a:r>
           </a:p>
           <a:p>
             <a:pPr/>
             <a:r>
-              <a:t>Low precision → analyst fatigue from false alarms</a:t>
+              <a:t>False Positive (FP) — false alarm (benign flagged as attack)</a:t>
             </a:r>
           </a:p>
           <a:p>
             <a:pPr/>
             <a:r>
-              <a:t>High precision → every alert is worth investigating</a:t>
-            </a:r>
-          </a:p>
-          <a:p>
-            <a:pPr/>
-            <a:r>
-              <a:t>When precision matters most:</a:t>
-            </a:r>
-          </a:p>
-          <a:p>
-            <a:pPr lvl="1"/>
-            <a:r>
-              <a:t>Automated blocking rules — you cannot afford to block legitimate traffic</a:t>
-            </a:r>
-          </a:p>
-          <a:p>
-            <a:pPr lvl="1"/>
-            <a:r>
-              <a:t>High-cost response actions (e.g. isolating a production server)</a:t>
+              <a:t>False Negative (FN) — missed attack (the dangerous one)</a:t>
             </a:r>
           </a:p>
         </p:txBody>
@@ -9806,12 +10008,12 @@
       <p:grpSpPr/>
       <p:sp>
         <p:nvSpPr>
-          <p:cNvPr id="2" name="Title 1"/>
+          <p:cNvPr id="2" name="Text Placeholder 1"/>
           <p:cNvSpPr>
             <a:spLocks noGrp="1"/>
           </p:cNvSpPr>
           <p:nvPr>
-            <p:ph type="title"/>
+            <p:ph type="body" idx="13" sz="quarter"/>
           </p:nvPr>
         </p:nvSpPr>
         <p:spPr/>
@@ -9820,19 +10022,24 @@
           <a:lstStyle/>
           <a:p>
             <a:r>
-              <a:t>Recall (Sensitivity)</a:t>
-            </a:r>
-          </a:p>
-        </p:txBody>
-      </p:sp>
-      <p:sp>
-        <p:nvSpPr>
-          <p:cNvPr id="3" name="Content Placeholder 2"/>
+              <a:t>Precision, Recall,</a:t>
+            </a:r>
+          </a:p>
+          <a:p>
+            <a:r>
+              <a:t>and F1</a:t>
+            </a:r>
+          </a:p>
+        </p:txBody>
+      </p:sp>
+      <p:sp>
+        <p:nvSpPr>
+          <p:cNvPr id="3" name="Text Placeholder 2"/>
           <p:cNvSpPr>
             <a:spLocks noGrp="1"/>
           </p:cNvSpPr>
           <p:nvPr>
-            <p:ph idx="1"/>
+            <p:ph type="body" idx="16" sz="quarter"/>
           </p:nvPr>
         </p:nvSpPr>
         <p:spPr/>
@@ -9840,51 +10047,8 @@
           <a:bodyPr/>
           <a:lstStyle/>
           <a:p>
-            <a:pPr/>
-            <a:r>
-              <a:t>"Of all real attacks, how many did my model catch?"</a:t>
-            </a:r>
-          </a:p>
-          <a:p>
-            <a:pPr/>
-            <a:r>
-              <a:t>Recall = TP / (TP + FN)</a:t>
-            </a:r>
-          </a:p>
-          <a:p>
-            <a:pPr/>
-            <a:r>
-              <a:t>Low recall → attacks slipping through undetected</a:t>
-            </a:r>
-          </a:p>
-          <a:p>
-            <a:pPr/>
-            <a:r>
-              <a:t>High recall → catching nearly every threat</a:t>
-            </a:r>
-          </a:p>
-          <a:p>
-            <a:pPr/>
-            <a:r>
-              <a:t>When recall matters most:</a:t>
-            </a:r>
-          </a:p>
-          <a:p>
-            <a:pPr lvl="1"/>
-            <a:r>
-              <a:t>Critical infrastructure monitoring — cannot miss an attack</a:t>
-            </a:r>
-          </a:p>
-          <a:p>
-            <a:pPr lvl="1"/>
-            <a:r>
-              <a:t>Compliance requirements — must detect certain threat types</a:t>
-            </a:r>
-          </a:p>
-          <a:p>
-            <a:pPr/>
-            <a:r>
-              <a:t>In security, recall is often the more critical metric</a:t>
+            <a:r>
+              <a:t>03</a:t>
             </a:r>
           </a:p>
         </p:txBody>

</xml_diff>